<commit_message>
docs: sync deck & video script with PDF, handwriting and engine-selector features
</commit_message>
<xml_diff>
--- a/docs/Kannada_Lipi_Mitra_Presentation.pptx
+++ b/docs/Kannada_Lipi_Mitra_Presentation.pptx
@@ -5292,7 +5292,7 @@
                 </a:solidFill>
                 <a:latin typeface="Segoe UI"/>
               </a:rPr>
-              <a:t>One OCR Manager routes to Gemini, Groq or fully-offline Tesseract — swap engines by config or per request. No vendor lock-in, no dead end when a quota runs out.</a:t>
+              <a:t>One OCR Manager routes to Gemini, Groq or fully-offline Tesseract — pick via the header dropdown or Auto. If an engine isn't ready, it auto-falls back. No lock-in, no dead end when a quota runs out.</a:t>
             </a:r>
           </a:p>
         </p:txBody>
@@ -5626,7 +5626,7 @@
                 </a:solidFill>
                 <a:latin typeface="Segoe UI"/>
               </a:rPr>
-              <a:t>Understand + hear, not just extract</a:t>
+              <a:t>Images, PDFs &amp; handwriting</a:t>
             </a:r>
           </a:p>
         </p:txBody>
@@ -5668,7 +5668,7 @@
                 </a:solidFill>
                 <a:latin typeface="Segoe UI"/>
               </a:rPr>
-              <a:t>One-click translation to English/Hindi and authentic Kannada text-to-speech (browser voice + gTTS fallback) — accessible to non-readers &amp; the visually impaired.</a:t>
+              <a:t>Upload, drag-drop, camera capture or multi-page PDF (page-wise OCR with per-page markers); plus a handwriting sample — covering every input type PS-05 names.</a:t>
             </a:r>
           </a:p>
         </p:txBody>
@@ -5814,7 +5814,7 @@
                 </a:solidFill>
                 <a:latin typeface="Segoe UI"/>
               </a:rPr>
-              <a:t>Searchable from second one</a:t>
+              <a:t>Understand + hear, not just extract</a:t>
             </a:r>
           </a:p>
         </p:txBody>
@@ -5856,7 +5856,7 @@
                 </a:solidFill>
                 <a:latin typeface="Segoe UI"/>
               </a:rPr>
-              <a:t>In-text search with live highlighting, editable transcription, copy / TXT export / print-to-PDF — a workstation, not a text box.</a:t>
+              <a:t>One-click translation to English/Hindi and authentic Kannada text-to-speech — plus in-text search, editable text, copy / TXT / print-to-PDF. Accessible to non-readers &amp; the visually impaired.</a:t>
             </a:r>
           </a:p>
         </p:txBody>
@@ -6112,8 +6112,8 @@
                 </a:solidFill>
                 <a:latin typeface="Segoe UI"/>
               </a:rPr>
-              <a:t>Image input
-upload · camera · sample</a:t>
+              <a:t>Input
+image · camera · PDF · handwriting</a:t>
             </a:r>
           </a:p>
         </p:txBody>
@@ -6305,7 +6305,7 @@
                 <a:latin typeface="Segoe UI"/>
               </a:rPr>
               <a:t>UnifiedOCRManager
-engine selection</a:t>
+engine + auto-fallback</a:t>
             </a:r>
           </a:p>
         </p:txBody>
@@ -8205,7 +8205,7 @@
                 </a:solidFill>
                 <a:latin typeface="Segoe UI"/>
               </a:rPr>
-              <a:t>document image | editable Kannada text · search+highlight · translate · TTS · copy · TXT · print/PDF</a:t>
+              <a:t>image upload | camera capture | multi-page PDF (page-wise) | handwriting  →  edit · search · translate · TTS · export</a:t>
             </a:r>
           </a:p>
         </p:txBody>
@@ -8970,6 +8970,25 @@
                 <a:latin typeface="Segoe UI"/>
               </a:rPr>
               <a:t>•  Any Kannada document image becomes text you can search, edit, hear, translate and share</a:t>
+            </a:r>
+          </a:p>
+          <a:p>
+            <a:pPr algn="l">
+              <a:lnSpc>
+                <a:spcPct val="100000"/>
+              </a:lnSpc>
+              <a:spcAft>
+                <a:spcPts val="675"/>
+              </a:spcAft>
+            </a:pPr>
+            <a:r>
+              <a:rPr sz="1500" b="0">
+                <a:solidFill>
+                  <a:srgbClr val="242B3D"/>
+                </a:solidFill>
+                <a:latin typeface="Segoe UI"/>
+              </a:rPr>
+              <a:t>•  Handles images, multi-page PDFs and handwriting — every input type PS-05 asks for</a:t>
             </a:r>
           </a:p>
           <a:p>

</xml_diff>

<commit_message>
fix: retime video script to 5min, dedupe tech section, resilient Render build, add name to deck
</commit_message>
<xml_diff>
--- a/docs/Kannada_Lipi_Mitra_Presentation.pptx
+++ b/docs/Kannada_Lipi_Mitra_Presentation.pptx
@@ -3321,6 +3321,25 @@
             <a:spAutoFit/>
           </a:bodyPr>
           <a:lstStyle/>
+          <a:p>
+            <a:pPr algn="ctr">
+              <a:lnSpc>
+                <a:spcPct val="100000"/>
+              </a:lnSpc>
+              <a:spcAft>
+                <a:spcPts val="585"/>
+              </a:spcAft>
+            </a:pPr>
+            <a:r>
+              <a:rPr sz="1300" b="0">
+                <a:solidFill>
+                  <a:srgbClr val="B8C0D0"/>
+                </a:solidFill>
+                <a:latin typeface="Segoe UI"/>
+              </a:rPr>
+              <a:t>Participant: Ritika Bhati · github.com/Ritika-Bhati-2266/Kannada-Text-Digitization</a:t>
+            </a:r>
+          </a:p>
           <a:p>
             <a:pPr algn="ctr">
               <a:lnSpc>

</xml_diff>

<commit_message>
feat: Docker runtime for Render, multi-stage image, honest accuracy docs
- render.yaml: runtime docker + dockerfilePath, drop native Python build
- Dockerfile: Node frontend build -> python:3.12-slim + tesseract-ocr-kan
- .dockerignore: exclude **/.env (backend/.env leak), .git, node_modules
- README: Docker deploy path, Measured Accuracy (4 synthetic, CER only)
- make_ppt: Docker tech stack; regenerate pptx; sample 4 labelled simulated
</commit_message>
<xml_diff>
--- a/docs/Kannada_Lipi_Mitra_Presentation.pptx
+++ b/docs/Kannada_Lipi_Mitra_Presentation.pptx
@@ -13,6 +13,7 @@
     <p:sldId id="261" r:id="rId12"/>
     <p:sldId id="262" r:id="rId13"/>
     <p:sldId id="263" r:id="rId14"/>
+    <p:sldId id="264" r:id="rId15"/>
   </p:sldIdLst>
   <p:sldSz cx="12191695" cy="6858000" type="screen4x3"/>
   <p:notesSz cx="6858000" cy="9144000"/>
@@ -3537,7 +3538,7 @@
                 </a:solidFill>
                 <a:latin typeface="Segoe UI"/>
               </a:rPr>
-              <a:t>Convert Kannada text from images, scans or handwriting into searchable digital text — and make it easier to understand and access</a:t>
+              <a:t>The assignment: convert Kannada text from images, scanned documents or handwritten material into searchable digital text — and make it easier to understand and access</a:t>
             </a:r>
           </a:p>
         </p:txBody>
@@ -3957,7 +3958,7 @@
                 </a:solidFill>
                 <a:latin typeface="Segoe UI"/>
               </a:rPr>
-              <a:t>2/8</a:t>
+              <a:t>2/9</a:t>
             </a:r>
           </a:p>
         </p:txBody>
@@ -4286,7 +4287,7 @@
                 <a:latin typeface="Segoe UI"/>
               </a:rPr>
               <a:t>Traditional OCR
-(Tesseract + kann data)</a:t>
+(Tesseract + kan data)</a:t>
             </a:r>
           </a:p>
         </p:txBody>
@@ -5003,7 +5004,7 @@
                 </a:solidFill>
                 <a:latin typeface="Segoe UI"/>
               </a:rPr>
-              <a:t>3/8</a:t>
+              <a:t>3/9</a:t>
             </a:r>
           </a:p>
         </p:txBody>
@@ -5269,7 +5270,7 @@
                 </a:solidFill>
                 <a:latin typeface="Segoe UI"/>
               </a:rPr>
-              <a:t>Engine-agnostic core</a:t>
+              <a:t>Offline-first, two engines</a:t>
             </a:r>
           </a:p>
         </p:txBody>
@@ -5311,7 +5312,7 @@
                 </a:solidFill>
                 <a:latin typeface="Segoe UI"/>
               </a:rPr>
-              <a:t>One OCR Manager routes to Gemini, Groq or fully-offline Tesseract — pick via the header dropdown or Auto. If an engine isn't ready, it auto-falls back. No lock-in, no dead end when a quota runs out.</a:t>
+              <a:t>One OCR Manager routes to offline Tesseract (default) or the optional Groq vision model — pick via the header dropdown. No API key needed: Tesseract runs end to end offline.</a:t>
             </a:r>
           </a:p>
         </p:txBody>
@@ -5499,7 +5500,7 @@
                 </a:solidFill>
                 <a:latin typeface="Segoe UI"/>
               </a:rPr>
-              <a:t>Post-extraction Unicode analysis (Kannada / Devanagari / Latin shares) with an automatic targeted retry — catches silent failures traditional OCR never detects.</a:t>
+              <a:t>Post-extraction Unicode analysis (Kannada / Devanagari / Latin shares) on every result; on the Groq path, a wrong-script answer triggers one targeted retry — a class of silent failure raw OCR never reports.</a:t>
             </a:r>
           </a:p>
         </p:txBody>
@@ -5645,7 +5646,7 @@
                 </a:solidFill>
                 <a:latin typeface="Segoe UI"/>
               </a:rPr>
-              <a:t>Images, PDFs &amp; handwriting</a:t>
+              <a:t>Images, PDFs &amp; samples</a:t>
             </a:r>
           </a:p>
         </p:txBody>
@@ -5687,7 +5688,7 @@
                 </a:solidFill>
                 <a:latin typeface="Segoe UI"/>
               </a:rPr>
-              <a:t>Upload, drag-drop, camera capture or multi-page PDF (page-wise OCR with per-page markers); plus a handwriting sample — covering every input type PS-05 names.</a:t>
+              <a:t>Upload, drag-drop, camera capture or multi-page PDF (page-wise OCR with per-page markers); plus four sample documents — sample 4 is simulated handwriting generated by script, not real handwriting.</a:t>
             </a:r>
           </a:p>
         </p:txBody>
@@ -5875,7 +5876,7 @@
                 </a:solidFill>
                 <a:latin typeface="Segoe UI"/>
               </a:rPr>
-              <a:t>One-click translation to English/Hindi and authentic Kannada text-to-speech — plus in-text search, editable text, copy / TXT / print-to-PDF. Accessible to non-readers &amp; the visually impaired.</a:t>
+              <a:t>One-click translation to English/Hindi (needs the optional Groq key; the UI says so plainly when it's missing) and authentic Kannada text-to-speech — plus in-text search, editable text, copy / TXT / print-to-PDF.</a:t>
             </a:r>
           </a:p>
         </p:txBody>
@@ -5959,7 +5960,7 @@
                 </a:solidFill>
                 <a:latin typeface="Segoe UI"/>
               </a:rPr>
-              <a:t>4/8</a:t>
+              <a:t>4/9</a:t>
             </a:r>
           </a:p>
         </p:txBody>
@@ -6132,7 +6133,7 @@
                 <a:latin typeface="Segoe UI"/>
               </a:rPr>
               <a:t>Input
-image · camera · PDF · handwriting</a:t>
+image · camera · PDF · samples</a:t>
             </a:r>
           </a:p>
         </p:txBody>
@@ -6324,7 +6325,7 @@
                 <a:latin typeface="Segoe UI"/>
               </a:rPr>
               <a:t>UnifiedOCRManager
-engine + auto-fallback</a:t>
+engine selection</a:t>
             </a:r>
           </a:p>
         </p:txBody>
@@ -6419,8 +6420,8 @@
                 </a:solidFill>
                 <a:latin typeface="Segoe UI"/>
               </a:rPr>
-              <a:t>Vision / OCR engine
-gemini | groq | tesseract</a:t>
+              <a:t>OCR engine
+tesseract (default) | groq</a:t>
             </a:r>
           </a:p>
         </p:txBody>
@@ -6515,7 +6516,8 @@
                 </a:solidFill>
                 <a:latin typeface="Segoe UI"/>
               </a:rPr>
-              <a:t>Script-distribution check — issue? one smart retry prompt</a:t>
+              <a:t>Script-distribution check (both engines)
+Groq path only: issue? one smart retry</a:t>
             </a:r>
           </a:p>
         </p:txBody>
@@ -6718,7 +6720,7 @@
               </a:rPr>
               <a:t>Translate API
 Kannada → EN / HI
-LLM-powered</a:t>
+needs optional Groq key</a:t>
             </a:r>
           </a:p>
         </p:txBody>
@@ -6814,7 +6816,7 @@
                 </a:solidFill>
                 <a:latin typeface="Segoe UI"/>
               </a:rPr>
-              <a:t>Design decisions: manager pattern (engine = config) · deterministic Unicode validation (cheap, reliable) · same-origin deploy (one URL, zero CORS)</a:t>
+              <a:t>Design decisions: manager pattern (engine = config) · deterministic Unicode validation · Groq path adds retry + Tesseract cross-check · same-origin deploy</a:t>
             </a:r>
           </a:p>
         </p:txBody>
@@ -6898,7 +6900,7 @@
                 </a:solidFill>
                 <a:latin typeface="Segoe UI"/>
               </a:rPr>
-              <a:t>5/8</a:t>
+              <a:t>5/9</a:t>
             </a:r>
           </a:p>
         </p:txBody>
@@ -7570,7 +7572,7 @@
                 </a:solidFill>
                 <a:latin typeface="Segoe UI"/>
               </a:rPr>
-              <a:t>•  Gemini 2.0 Flash (vision LLM)</a:t>
+              <a:t>•  Tesseract + OpenCV (offline, default)</a:t>
             </a:r>
           </a:p>
           <a:p>
@@ -7589,7 +7591,7 @@
                 </a:solidFill>
                 <a:latin typeface="Segoe UI"/>
               </a:rPr>
-              <a:t>•  Groq open vision LLM</a:t>
+              <a:t>•  Groq open vision LLM (optional)</a:t>
             </a:r>
           </a:p>
           <a:p>
@@ -7608,7 +7610,7 @@
                 </a:solidFill>
                 <a:latin typeface="Segoe UI"/>
               </a:rPr>
-              <a:t>•  Tesseract + OpenCV (offline)</a:t>
+              <a:t>•  Script stats + user warnings</a:t>
             </a:r>
           </a:p>
           <a:p>
@@ -7627,136 +7629,9 @@
                 </a:solidFill>
                 <a:latin typeface="Segoe UI"/>
               </a:rPr>
-              <a:t>•  LLM translation EN / HI</a:t>
-            </a:r>
-          </a:p>
-        </p:txBody>
-      </p:sp>
-      <p:sp>
-        <p:nvSpPr>
-          <p:cNvPr id="13" name="Rounded Rectangle 12"/>
-          <p:cNvSpPr/>
-          <p:nvPr/>
-        </p:nvSpPr>
-        <p:spPr>
-          <a:xfrm>
-            <a:off x="9326880" y="1554480"/>
-            <a:ext cx="2697480" cy="548640"/>
-          </a:xfrm>
-          <a:prstGeom prst="roundRect">
-            <a:avLst/>
-          </a:prstGeom>
-          <a:solidFill>
-            <a:srgbClr val="6A1B9A"/>
-          </a:solidFill>
-          <a:ln>
-            <a:noFill/>
-          </a:ln>
-        </p:spPr>
-        <p:style>
-          <a:lnRef idx="1">
-            <a:schemeClr val="accent1"/>
-          </a:lnRef>
-          <a:fillRef idx="3">
-            <a:schemeClr val="accent1"/>
-          </a:fillRef>
-          <a:effectRef idx="2">
-            <a:schemeClr val="accent1"/>
-          </a:effectRef>
-          <a:fontRef idx="minor">
-            <a:schemeClr val="lt1"/>
-          </a:fontRef>
-        </p:style>
-        <p:txBody>
-          <a:bodyPr rtlCol="0" anchor="ctr" wrap="square" lIns="109728" rIns="109728"/>
-          <a:lstStyle/>
-          <a:p>
-            <a:pPr algn="ctr"/>
-            <a:r>
-              <a:rPr sz="1700" b="1">
-                <a:solidFill>
-                  <a:srgbClr val="FFFFFF"/>
-                </a:solidFill>
-                <a:latin typeface="Segoe UI"/>
-              </a:rPr>
-              <a:t>DevOps</a:t>
-            </a:r>
-          </a:p>
-        </p:txBody>
-      </p:sp>
-      <p:sp>
-        <p:nvSpPr>
-          <p:cNvPr id="14" name="Rounded Rectangle 13"/>
-          <p:cNvSpPr/>
-          <p:nvPr/>
-        </p:nvSpPr>
-        <p:spPr>
-          <a:xfrm>
-            <a:off x="9326880" y="2148840"/>
-            <a:ext cx="2697480" cy="3108960"/>
-          </a:xfrm>
-          <a:prstGeom prst="roundRect">
-            <a:avLst/>
-          </a:prstGeom>
-          <a:solidFill>
-            <a:srgbClr val="F5F6FA"/>
-          </a:solidFill>
-          <a:ln>
-            <a:noFill/>
-          </a:ln>
-        </p:spPr>
-        <p:style>
-          <a:lnRef idx="1">
-            <a:schemeClr val="accent1"/>
-          </a:lnRef>
-          <a:fillRef idx="3">
-            <a:schemeClr val="accent1"/>
-          </a:fillRef>
-          <a:effectRef idx="2">
-            <a:schemeClr val="accent1"/>
-          </a:effectRef>
-          <a:fontRef idx="minor">
-            <a:schemeClr val="lt1"/>
-          </a:fontRef>
-        </p:style>
-        <p:txBody>
-          <a:bodyPr rtlCol="0" anchor="ctr" wrap="square" lIns="109728" rIns="109728"/>
-          <a:lstStyle/>
-          <a:p>
-            <a:pPr algn="l"/>
-            <a:r>
-              <a:rPr sz="1200" b="0">
-                <a:solidFill>
-                  <a:srgbClr val="242B3D"/>
-                </a:solidFill>
-                <a:latin typeface="Segoe UI"/>
-              </a:rPr>
-              <a:t/>
-            </a:r>
-          </a:p>
-        </p:txBody>
-      </p:sp>
-      <p:sp>
-        <p:nvSpPr>
-          <p:cNvPr id="15" name="TextBox 14"/>
-          <p:cNvSpPr txBox="1"/>
-          <p:nvPr/>
-        </p:nvSpPr>
-        <p:spPr>
-          <a:xfrm>
-            <a:off x="9509760" y="2331720"/>
-            <a:ext cx="2377440" cy="2743200"/>
-          </a:xfrm>
-          <a:prstGeom prst="rect">
-            <a:avLst/>
-          </a:prstGeom>
-          <a:noFill/>
-        </p:spPr>
-        <p:txBody>
-          <a:bodyPr wrap="square">
-            <a:spAutoFit/>
-          </a:bodyPr>
-          <a:lstStyle/>
+              <a:t>•  Groq path: smart retry + cross-check</a:t>
+            </a:r>
+          </a:p>
           <a:p>
             <a:pPr algn="l">
               <a:lnSpc>
@@ -7773,9 +7648,136 @@
                 </a:solidFill>
                 <a:latin typeface="Segoe UI"/>
               </a:rPr>
-              <a:t>•  Render single web service</a:t>
-            </a:r>
-          </a:p>
+              <a:t>•  Translation needs optional Groq key</a:t>
+            </a:r>
+          </a:p>
+        </p:txBody>
+      </p:sp>
+      <p:sp>
+        <p:nvSpPr>
+          <p:cNvPr id="13" name="Rounded Rectangle 12"/>
+          <p:cNvSpPr/>
+          <p:nvPr/>
+        </p:nvSpPr>
+        <p:spPr>
+          <a:xfrm>
+            <a:off x="9326880" y="1554480"/>
+            <a:ext cx="2697480" cy="548640"/>
+          </a:xfrm>
+          <a:prstGeom prst="roundRect">
+            <a:avLst/>
+          </a:prstGeom>
+          <a:solidFill>
+            <a:srgbClr val="6A1B9A"/>
+          </a:solidFill>
+          <a:ln>
+            <a:noFill/>
+          </a:ln>
+        </p:spPr>
+        <p:style>
+          <a:lnRef idx="1">
+            <a:schemeClr val="accent1"/>
+          </a:lnRef>
+          <a:fillRef idx="3">
+            <a:schemeClr val="accent1"/>
+          </a:fillRef>
+          <a:effectRef idx="2">
+            <a:schemeClr val="accent1"/>
+          </a:effectRef>
+          <a:fontRef idx="minor">
+            <a:schemeClr val="lt1"/>
+          </a:fontRef>
+        </p:style>
+        <p:txBody>
+          <a:bodyPr rtlCol="0" anchor="ctr" wrap="square" lIns="109728" rIns="109728"/>
+          <a:lstStyle/>
+          <a:p>
+            <a:pPr algn="ctr"/>
+            <a:r>
+              <a:rPr sz="1700" b="1">
+                <a:solidFill>
+                  <a:srgbClr val="FFFFFF"/>
+                </a:solidFill>
+                <a:latin typeface="Segoe UI"/>
+              </a:rPr>
+              <a:t>DevOps</a:t>
+            </a:r>
+          </a:p>
+        </p:txBody>
+      </p:sp>
+      <p:sp>
+        <p:nvSpPr>
+          <p:cNvPr id="14" name="Rounded Rectangle 13"/>
+          <p:cNvSpPr/>
+          <p:nvPr/>
+        </p:nvSpPr>
+        <p:spPr>
+          <a:xfrm>
+            <a:off x="9326880" y="2148840"/>
+            <a:ext cx="2697480" cy="3108960"/>
+          </a:xfrm>
+          <a:prstGeom prst="roundRect">
+            <a:avLst/>
+          </a:prstGeom>
+          <a:solidFill>
+            <a:srgbClr val="F5F6FA"/>
+          </a:solidFill>
+          <a:ln>
+            <a:noFill/>
+          </a:ln>
+        </p:spPr>
+        <p:style>
+          <a:lnRef idx="1">
+            <a:schemeClr val="accent1"/>
+          </a:lnRef>
+          <a:fillRef idx="3">
+            <a:schemeClr val="accent1"/>
+          </a:fillRef>
+          <a:effectRef idx="2">
+            <a:schemeClr val="accent1"/>
+          </a:effectRef>
+          <a:fontRef idx="minor">
+            <a:schemeClr val="lt1"/>
+          </a:fontRef>
+        </p:style>
+        <p:txBody>
+          <a:bodyPr rtlCol="0" anchor="ctr" wrap="square" lIns="109728" rIns="109728"/>
+          <a:lstStyle/>
+          <a:p>
+            <a:pPr algn="l"/>
+            <a:r>
+              <a:rPr sz="1200" b="0">
+                <a:solidFill>
+                  <a:srgbClr val="242B3D"/>
+                </a:solidFill>
+                <a:latin typeface="Segoe UI"/>
+              </a:rPr>
+              <a:t/>
+            </a:r>
+          </a:p>
+        </p:txBody>
+      </p:sp>
+      <p:sp>
+        <p:nvSpPr>
+          <p:cNvPr id="15" name="TextBox 14"/>
+          <p:cNvSpPr txBox="1"/>
+          <p:nvPr/>
+        </p:nvSpPr>
+        <p:spPr>
+          <a:xfrm>
+            <a:off x="9509760" y="2331720"/>
+            <a:ext cx="2377440" cy="2743200"/>
+          </a:xfrm>
+          <a:prstGeom prst="rect">
+            <a:avLst/>
+          </a:prstGeom>
+          <a:noFill/>
+        </p:spPr>
+        <p:txBody>
+          <a:bodyPr wrap="square">
+            <a:spAutoFit/>
+          </a:bodyPr>
+          <a:lstStyle/>
           <a:p>
             <a:pPr algn="l">
               <a:lnSpc>
@@ -7792,7 +7794,7 @@
                 </a:solidFill>
                 <a:latin typeface="Segoe UI"/>
               </a:rPr>
-              <a:t>•  render.yaml blueprint</a:t>
+              <a:t>•  Render Docker runtime</a:t>
             </a:r>
           </a:p>
           <a:p>
@@ -7811,7 +7813,7 @@
                 </a:solidFill>
                 <a:latin typeface="Segoe UI"/>
               </a:rPr>
-              <a:t>•  env-var secrets (.env)</a:t>
+              <a:t>•  Dockerfile: Tesseract + tesseract-ocr-kan</a:t>
             </a:r>
           </a:p>
           <a:p>
@@ -7830,6 +7832,44 @@
                 </a:solidFill>
                 <a:latin typeface="Segoe UI"/>
               </a:rPr>
+              <a:t>•  multi-stage: Node build → Python image</a:t>
+            </a:r>
+          </a:p>
+          <a:p>
+            <a:pPr algn="l">
+              <a:lnSpc>
+                <a:spcPct val="105000"/>
+              </a:lnSpc>
+              <a:spcAft>
+                <a:spcPts val="585"/>
+              </a:spcAft>
+            </a:pPr>
+            <a:r>
+              <a:rPr sz="1300" b="0">
+                <a:solidFill>
+                  <a:srgbClr val="242B3D"/>
+                </a:solidFill>
+                <a:latin typeface="Segoe UI"/>
+              </a:rPr>
+              <a:t>•  env-var secrets (never committed)</a:t>
+            </a:r>
+          </a:p>
+          <a:p>
+            <a:pPr algn="l">
+              <a:lnSpc>
+                <a:spcPct val="105000"/>
+              </a:lnSpc>
+              <a:spcAft>
+                <a:spcPts val="585"/>
+              </a:spcAft>
+            </a:pPr>
+            <a:r>
+              <a:rPr sz="1300" b="0">
+                <a:solidFill>
+                  <a:srgbClr val="242B3D"/>
+                </a:solidFill>
+                <a:latin typeface="Segoe UI"/>
+              </a:rPr>
               <a:t>•  GitHub · Swagger /docs</a:t>
             </a:r>
           </a:p>
@@ -7966,7 +8006,7 @@
                 </a:solidFill>
                 <a:latin typeface="Segoe UI"/>
               </a:rPr>
-              <a:t>6/8</a:t>
+              <a:t>6/9</a:t>
             </a:r>
           </a:p>
         </p:txBody>
@@ -8224,7 +8264,7 @@
                 </a:solidFill>
                 <a:latin typeface="Segoe UI"/>
               </a:rPr>
-              <a:t>image upload | camera capture | multi-page PDF (page-wise) | handwriting  →  edit · search · translate · TTS · export</a:t>
+              <a:t>image upload | camera capture | multi-page PDF (page-wise) | sample docs  →  edit · search · translate · TTS · export</a:t>
             </a:r>
           </a:p>
         </p:txBody>
@@ -8456,7 +8496,7 @@
                 </a:solidFill>
                 <a:latin typeface="Segoe UI"/>
               </a:rPr>
-              <a:t>UnifiedOCRManager — engine selection, readiness checks, fallback</a:t>
+              <a:t>UnifiedOCRManager — engine selection &amp; readiness checks</a:t>
             </a:r>
           </a:p>
         </p:txBody>
@@ -8469,14 +8509,14 @@
         </p:nvSpPr>
         <p:spPr>
           <a:xfrm>
-            <a:off x="1828800" y="5074920"/>
+            <a:off x="3291840" y="5074920"/>
             <a:ext cx="2651760" cy="868680"/>
           </a:xfrm>
           <a:prstGeom prst="roundRect">
             <a:avLst/>
           </a:prstGeom>
           <a:solidFill>
-            <a:srgbClr val="00796B"/>
+            <a:srgbClr val="5A6472"/>
           </a:solidFill>
           <a:ln>
             <a:noFill/>
@@ -8508,8 +8548,8 @@
                 </a:solidFill>
                 <a:latin typeface="Segoe UI"/>
               </a:rPr>
-              <a:t>Gemini 2.0 Flash
-multimodal LLM</a:t>
+              <a:t>Tesseract + OpenCV
+offline OCR (default)</a:t>
             </a:r>
           </a:p>
         </p:txBody>
@@ -8522,7 +8562,7 @@
         </p:nvSpPr>
         <p:spPr>
           <a:xfrm>
-            <a:off x="4754880" y="5074920"/>
+            <a:off x="6217920" y="5074920"/>
             <a:ext cx="2651760" cy="868680"/>
           </a:xfrm>
           <a:prstGeom prst="roundRect">
@@ -8562,67 +8602,14 @@
                 <a:latin typeface="Segoe UI"/>
               </a:rPr>
               <a:t>Groq
-open vision LLM</a:t>
-            </a:r>
-          </a:p>
-        </p:txBody>
-      </p:sp>
-      <p:sp>
-        <p:nvSpPr>
-          <p:cNvPr id="14" name="Rounded Rectangle 13"/>
-          <p:cNvSpPr/>
-          <p:nvPr/>
-        </p:nvSpPr>
-        <p:spPr>
-          <a:xfrm>
-            <a:off x="7680960" y="5074920"/>
-            <a:ext cx="2651760" cy="868680"/>
-          </a:xfrm>
-          <a:prstGeom prst="roundRect">
-            <a:avLst/>
-          </a:prstGeom>
-          <a:solidFill>
-            <a:srgbClr val="5A6472"/>
-          </a:solidFill>
-          <a:ln>
-            <a:noFill/>
-          </a:ln>
-        </p:spPr>
-        <p:style>
-          <a:lnRef idx="1">
-            <a:schemeClr val="accent1"/>
-          </a:lnRef>
-          <a:fillRef idx="3">
-            <a:schemeClr val="accent1"/>
-          </a:fillRef>
-          <a:effectRef idx="2">
-            <a:schemeClr val="accent1"/>
-          </a:effectRef>
-          <a:fontRef idx="minor">
-            <a:schemeClr val="lt1"/>
-          </a:fontRef>
-        </p:style>
-        <p:txBody>
-          <a:bodyPr rtlCol="0" anchor="ctr" wrap="square" lIns="109728" rIns="109728"/>
-          <a:lstStyle/>
-          <a:p>
-            <a:pPr algn="ctr"/>
-            <a:r>
-              <a:rPr sz="1300" b="1">
-                <a:solidFill>
-                  <a:srgbClr val="FFFFFF"/>
-                </a:solidFill>
-                <a:latin typeface="Segoe UI"/>
-              </a:rPr>
-              <a:t>Tesseract + OpenCV
-offline OCR</a:t>
-            </a:r>
-          </a:p>
-        </p:txBody>
-      </p:sp>
-      <p:sp>
-        <p:nvSpPr>
-          <p:cNvPr id="15" name="Down Arrow 14"/>
+open vision LLM (optional)</a:t>
+            </a:r>
+          </a:p>
+        </p:txBody>
+      </p:sp>
+      <p:sp>
+        <p:nvSpPr>
+          <p:cNvPr id="14" name="Down Arrow 13"/>
           <p:cNvSpPr/>
           <p:nvPr/>
         </p:nvSpPr>
@@ -8665,7 +8652,7 @@
       </p:sp>
       <p:sp>
         <p:nvSpPr>
-          <p:cNvPr id="16" name="TextBox 15"/>
+          <p:cNvPr id="15" name="TextBox 14"/>
           <p:cNvSpPr txBox="1"/>
           <p:nvPr/>
         </p:nvSpPr>
@@ -8700,14 +8687,14 @@
                 </a:solidFill>
                 <a:latin typeface="Segoe UI"/>
               </a:rPr>
-              <a:t>script validation + retry · translation · gTTS fallback</a:t>
-            </a:r>
-          </a:p>
-        </p:txBody>
-      </p:sp>
-      <p:sp>
-        <p:nvSpPr>
-          <p:cNvPr id="17" name="TextBox 16"/>
+              <a:t>script stats + warnings · Groq path: retry + cross-check · translation (optional key) · gTTS fallback</a:t>
+            </a:r>
+          </a:p>
+        </p:txBody>
+      </p:sp>
+      <p:sp>
+        <p:nvSpPr>
+          <p:cNvPr id="16" name="TextBox 15"/>
           <p:cNvSpPr txBox="1"/>
           <p:nvPr/>
         </p:nvSpPr>
@@ -8749,7 +8736,7 @@
       </p:sp>
       <p:sp>
         <p:nvSpPr>
-          <p:cNvPr id="18" name="TextBox 17"/>
+          <p:cNvPr id="17" name="TextBox 16"/>
           <p:cNvSpPr txBox="1"/>
           <p:nvPr/>
         </p:nvSpPr>
@@ -8784,7 +8771,7 @@
                 </a:solidFill>
                 <a:latin typeface="Segoe UI"/>
               </a:rPr>
-              <a:t>7/8</a:t>
+              <a:t>7/9</a:t>
             </a:r>
           </a:p>
         </p:txBody>
@@ -8904,6 +8891,1370 @@
                 </a:solidFill>
                 <a:latin typeface="Segoe UI"/>
               </a:rPr>
+              <a:t>Measured Accuracy — CER from compare_engines.py</a:t>
+            </a:r>
+          </a:p>
+        </p:txBody>
+      </p:sp>
+      <p:sp>
+        <p:nvSpPr>
+          <p:cNvPr id="4" name="TextBox 3"/>
+          <p:cNvSpPr txBox="1"/>
+          <p:nvPr/>
+        </p:nvSpPr>
+        <p:spPr>
+          <a:xfrm>
+            <a:off x="548640" y="960120"/>
+            <a:ext cx="11064240" cy="457200"/>
+          </a:xfrm>
+          <a:prstGeom prst="rect">
+            <a:avLst/>
+          </a:prstGeom>
+          <a:noFill/>
+        </p:spPr>
+        <p:txBody>
+          <a:bodyPr wrap="square">
+            <a:spAutoFit/>
+          </a:bodyPr>
+          <a:lstStyle/>
+          <a:p>
+            <a:pPr algn="l">
+              <a:lnSpc>
+                <a:spcPct val="100000"/>
+              </a:lnSpc>
+              <a:spcAft>
+                <a:spcPts val="675"/>
+              </a:spcAft>
+            </a:pPr>
+            <a:r>
+              <a:rPr sz="1500" b="0">
+                <a:solidFill>
+                  <a:srgbClr val="5A6472"/>
+                </a:solidFill>
+                <a:latin typeface="Segoe UI"/>
+              </a:rPr>
+              <a:t>Character error rate vs ground-truth text (lower is better, 0.00% = exact) · reproduce: python backend/compare_engines.py</a:t>
+            </a:r>
+          </a:p>
+        </p:txBody>
+      </p:sp>
+      <p:sp>
+        <p:nvSpPr>
+          <p:cNvPr id="5" name="Rounded Rectangle 4"/>
+          <p:cNvSpPr/>
+          <p:nvPr/>
+        </p:nvSpPr>
+        <p:spPr>
+          <a:xfrm>
+            <a:off x="548640" y="1554480"/>
+            <a:ext cx="3383280" cy="457200"/>
+          </a:xfrm>
+          <a:prstGeom prst="roundRect">
+            <a:avLst/>
+          </a:prstGeom>
+          <a:solidFill>
+            <a:srgbClr val="1A233B"/>
+          </a:solidFill>
+          <a:ln>
+            <a:noFill/>
+          </a:ln>
+        </p:spPr>
+        <p:style>
+          <a:lnRef idx="1">
+            <a:schemeClr val="accent1"/>
+          </a:lnRef>
+          <a:fillRef idx="3">
+            <a:schemeClr val="accent1"/>
+          </a:fillRef>
+          <a:effectRef idx="2">
+            <a:schemeClr val="accent1"/>
+          </a:effectRef>
+          <a:fontRef idx="minor">
+            <a:schemeClr val="lt1"/>
+          </a:fontRef>
+        </p:style>
+        <p:txBody>
+          <a:bodyPr rtlCol="0" anchor="ctr" wrap="square" lIns="109728" rIns="109728"/>
+          <a:lstStyle/>
+          <a:p>
+            <a:pPr algn="ctr"/>
+            <a:r>
+              <a:rPr sz="1300" b="1">
+                <a:solidFill>
+                  <a:srgbClr val="FFFFFF"/>
+                </a:solidFill>
+                <a:latin typeface="Segoe UI"/>
+              </a:rPr>
+              <a:t>Sample</a:t>
+            </a:r>
+          </a:p>
+        </p:txBody>
+      </p:sp>
+      <p:sp>
+        <p:nvSpPr>
+          <p:cNvPr id="6" name="Rounded Rectangle 5"/>
+          <p:cNvSpPr/>
+          <p:nvPr/>
+        </p:nvSpPr>
+        <p:spPr>
+          <a:xfrm>
+            <a:off x="3977639" y="1554480"/>
+            <a:ext cx="2468880" cy="457200"/>
+          </a:xfrm>
+          <a:prstGeom prst="roundRect">
+            <a:avLst/>
+          </a:prstGeom>
+          <a:solidFill>
+            <a:srgbClr val="0277BD"/>
+          </a:solidFill>
+          <a:ln>
+            <a:noFill/>
+          </a:ln>
+        </p:spPr>
+        <p:style>
+          <a:lnRef idx="1">
+            <a:schemeClr val="accent1"/>
+          </a:lnRef>
+          <a:fillRef idx="3">
+            <a:schemeClr val="accent1"/>
+          </a:fillRef>
+          <a:effectRef idx="2">
+            <a:schemeClr val="accent1"/>
+          </a:effectRef>
+          <a:fontRef idx="minor">
+            <a:schemeClr val="lt1"/>
+          </a:fontRef>
+        </p:style>
+        <p:txBody>
+          <a:bodyPr rtlCol="0" anchor="ctr" wrap="square" lIns="109728" rIns="109728"/>
+          <a:lstStyle/>
+          <a:p>
+            <a:pPr algn="ctr"/>
+            <a:r>
+              <a:rPr sz="1300" b="1">
+                <a:solidFill>
+                  <a:srgbClr val="FFFFFF"/>
+                </a:solidFill>
+                <a:latin typeface="Segoe UI"/>
+              </a:rPr>
+              <a:t>Groq (vision LLM)</a:t>
+            </a:r>
+          </a:p>
+        </p:txBody>
+      </p:sp>
+      <p:sp>
+        <p:nvSpPr>
+          <p:cNvPr id="7" name="Rounded Rectangle 6"/>
+          <p:cNvSpPr/>
+          <p:nvPr/>
+        </p:nvSpPr>
+        <p:spPr>
+          <a:xfrm>
+            <a:off x="6492240" y="1554480"/>
+            <a:ext cx="2468880" cy="457200"/>
+          </a:xfrm>
+          <a:prstGeom prst="roundRect">
+            <a:avLst/>
+          </a:prstGeom>
+          <a:solidFill>
+            <a:srgbClr val="5A6472"/>
+          </a:solidFill>
+          <a:ln>
+            <a:noFill/>
+          </a:ln>
+        </p:spPr>
+        <p:style>
+          <a:lnRef idx="1">
+            <a:schemeClr val="accent1"/>
+          </a:lnRef>
+          <a:fillRef idx="3">
+            <a:schemeClr val="accent1"/>
+          </a:fillRef>
+          <a:effectRef idx="2">
+            <a:schemeClr val="accent1"/>
+          </a:effectRef>
+          <a:fontRef idx="minor">
+            <a:schemeClr val="lt1"/>
+          </a:fontRef>
+        </p:style>
+        <p:txBody>
+          <a:bodyPr rtlCol="0" anchor="ctr" wrap="square" lIns="109728" rIns="109728"/>
+          <a:lstStyle/>
+          <a:p>
+            <a:pPr algn="ctr"/>
+            <a:r>
+              <a:rPr sz="1300" b="1">
+                <a:solidFill>
+                  <a:srgbClr val="FFFFFF"/>
+                </a:solidFill>
+                <a:latin typeface="Segoe UI"/>
+              </a:rPr>
+              <a:t>Tesseract psm 4</a:t>
+            </a:r>
+          </a:p>
+        </p:txBody>
+      </p:sp>
+      <p:sp>
+        <p:nvSpPr>
+          <p:cNvPr id="8" name="Rounded Rectangle 7"/>
+          <p:cNvSpPr/>
+          <p:nvPr/>
+        </p:nvSpPr>
+        <p:spPr>
+          <a:xfrm>
+            <a:off x="9006840" y="1554480"/>
+            <a:ext cx="2606040" cy="457200"/>
+          </a:xfrm>
+          <a:prstGeom prst="roundRect">
+            <a:avLst/>
+          </a:prstGeom>
+          <a:solidFill>
+            <a:srgbClr val="00796B"/>
+          </a:solidFill>
+          <a:ln>
+            <a:noFill/>
+          </a:ln>
+        </p:spPr>
+        <p:style>
+          <a:lnRef idx="1">
+            <a:schemeClr val="accent1"/>
+          </a:lnRef>
+          <a:fillRef idx="3">
+            <a:schemeClr val="accent1"/>
+          </a:fillRef>
+          <a:effectRef idx="2">
+            <a:schemeClr val="accent1"/>
+          </a:effectRef>
+          <a:fontRef idx="minor">
+            <a:schemeClr val="lt1"/>
+          </a:fontRef>
+        </p:style>
+        <p:txBody>
+          <a:bodyPr rtlCol="0" anchor="ctr" wrap="square" lIns="109728" rIns="109728"/>
+          <a:lstStyle/>
+          <a:p>
+            <a:pPr algn="ctr"/>
+            <a:r>
+              <a:rPr sz="1300" b="1">
+                <a:solidFill>
+                  <a:srgbClr val="FFFFFF"/>
+                </a:solidFill>
+                <a:latin typeface="Segoe UI"/>
+              </a:rPr>
+              <a:t>Tesseract psm 6 (default)</a:t>
+            </a:r>
+          </a:p>
+        </p:txBody>
+      </p:sp>
+      <p:sp>
+        <p:nvSpPr>
+          <p:cNvPr id="9" name="Rounded Rectangle 8"/>
+          <p:cNvSpPr/>
+          <p:nvPr/>
+        </p:nvSpPr>
+        <p:spPr>
+          <a:xfrm>
+            <a:off x="548640" y="2103120"/>
+            <a:ext cx="3383280" cy="566928"/>
+          </a:xfrm>
+          <a:prstGeom prst="roundRect">
+            <a:avLst/>
+          </a:prstGeom>
+          <a:solidFill>
+            <a:srgbClr val="F5F6FA"/>
+          </a:solidFill>
+          <a:ln>
+            <a:noFill/>
+          </a:ln>
+        </p:spPr>
+        <p:style>
+          <a:lnRef idx="1">
+            <a:schemeClr val="accent1"/>
+          </a:lnRef>
+          <a:fillRef idx="3">
+            <a:schemeClr val="accent1"/>
+          </a:fillRef>
+          <a:effectRef idx="2">
+            <a:schemeClr val="accent1"/>
+          </a:effectRef>
+          <a:fontRef idx="minor">
+            <a:schemeClr val="lt1"/>
+          </a:fontRef>
+        </p:style>
+        <p:txBody>
+          <a:bodyPr rtlCol="0" anchor="ctr" wrap="square" lIns="109728" rIns="109728"/>
+          <a:lstStyle/>
+          <a:p>
+            <a:pPr algn="l"/>
+            <a:r>
+              <a:rPr sz="1200" b="1">
+                <a:solidFill>
+                  <a:srgbClr val="1A233B"/>
+                </a:solidFill>
+                <a:latin typeface="Segoe UI"/>
+              </a:rPr>
+              <a:t>sample_circular.png</a:t>
+            </a:r>
+          </a:p>
+        </p:txBody>
+      </p:sp>
+      <p:sp>
+        <p:nvSpPr>
+          <p:cNvPr id="10" name="Rounded Rectangle 9"/>
+          <p:cNvSpPr/>
+          <p:nvPr/>
+        </p:nvSpPr>
+        <p:spPr>
+          <a:xfrm>
+            <a:off x="3977639" y="2103120"/>
+            <a:ext cx="2468880" cy="566928"/>
+          </a:xfrm>
+          <a:prstGeom prst="roundRect">
+            <a:avLst/>
+          </a:prstGeom>
+          <a:solidFill>
+            <a:srgbClr val="FFFFFF"/>
+          </a:solidFill>
+          <a:ln w="15875">
+            <a:solidFill>
+              <a:srgbClr val="5A6472"/>
+            </a:solidFill>
+          </a:ln>
+        </p:spPr>
+        <p:style>
+          <a:lnRef idx="1">
+            <a:schemeClr val="accent1"/>
+          </a:lnRef>
+          <a:fillRef idx="3">
+            <a:schemeClr val="accent1"/>
+          </a:fillRef>
+          <a:effectRef idx="2">
+            <a:schemeClr val="accent1"/>
+          </a:effectRef>
+          <a:fontRef idx="minor">
+            <a:schemeClr val="lt1"/>
+          </a:fontRef>
+        </p:style>
+        <p:txBody>
+          <a:bodyPr rtlCol="0" anchor="ctr" wrap="square" lIns="109728" rIns="109728"/>
+          <a:lstStyle/>
+          <a:p>
+            <a:pPr algn="ctr"/>
+            <a:r>
+              <a:rPr sz="1200" b="0">
+                <a:solidFill>
+                  <a:srgbClr val="242B3D"/>
+                </a:solidFill>
+                <a:latin typeface="Segoe UI"/>
+              </a:rPr>
+              <a:t>52.35%  (48.9s)</a:t>
+            </a:r>
+          </a:p>
+        </p:txBody>
+      </p:sp>
+      <p:sp>
+        <p:nvSpPr>
+          <p:cNvPr id="11" name="Rounded Rectangle 10"/>
+          <p:cNvSpPr/>
+          <p:nvPr/>
+        </p:nvSpPr>
+        <p:spPr>
+          <a:xfrm>
+            <a:off x="6492240" y="2103120"/>
+            <a:ext cx="2468880" cy="566928"/>
+          </a:xfrm>
+          <a:prstGeom prst="roundRect">
+            <a:avLst/>
+          </a:prstGeom>
+          <a:solidFill>
+            <a:srgbClr val="FFFFFF"/>
+          </a:solidFill>
+          <a:ln w="15875">
+            <a:solidFill>
+              <a:srgbClr val="5A6472"/>
+            </a:solidFill>
+          </a:ln>
+        </p:spPr>
+        <p:style>
+          <a:lnRef idx="1">
+            <a:schemeClr val="accent1"/>
+          </a:lnRef>
+          <a:fillRef idx="3">
+            <a:schemeClr val="accent1"/>
+          </a:fillRef>
+          <a:effectRef idx="2">
+            <a:schemeClr val="accent1"/>
+          </a:effectRef>
+          <a:fontRef idx="minor">
+            <a:schemeClr val="lt1"/>
+          </a:fontRef>
+        </p:style>
+        <p:txBody>
+          <a:bodyPr rtlCol="0" anchor="ctr" wrap="square" lIns="109728" rIns="109728"/>
+          <a:lstStyle/>
+          <a:p>
+            <a:pPr algn="ctr"/>
+            <a:r>
+              <a:rPr sz="1200" b="0">
+                <a:solidFill>
+                  <a:srgbClr val="242B3D"/>
+                </a:solidFill>
+                <a:latin typeface="Segoe UI"/>
+              </a:rPr>
+              <a:t>20.75%  (0.84s)</a:t>
+            </a:r>
+          </a:p>
+        </p:txBody>
+      </p:sp>
+      <p:sp>
+        <p:nvSpPr>
+          <p:cNvPr id="12" name="Rounded Rectangle 11"/>
+          <p:cNvSpPr/>
+          <p:nvPr/>
+        </p:nvSpPr>
+        <p:spPr>
+          <a:xfrm>
+            <a:off x="9006840" y="2103120"/>
+            <a:ext cx="2606040" cy="566928"/>
+          </a:xfrm>
+          <a:prstGeom prst="roundRect">
+            <a:avLst/>
+          </a:prstGeom>
+          <a:solidFill>
+            <a:srgbClr val="FFFFFF"/>
+          </a:solidFill>
+          <a:ln w="15875">
+            <a:solidFill>
+              <a:srgbClr val="5A6472"/>
+            </a:solidFill>
+          </a:ln>
+        </p:spPr>
+        <p:style>
+          <a:lnRef idx="1">
+            <a:schemeClr val="accent1"/>
+          </a:lnRef>
+          <a:fillRef idx="3">
+            <a:schemeClr val="accent1"/>
+          </a:fillRef>
+          <a:effectRef idx="2">
+            <a:schemeClr val="accent1"/>
+          </a:effectRef>
+          <a:fontRef idx="minor">
+            <a:schemeClr val="lt1"/>
+          </a:fontRef>
+        </p:style>
+        <p:txBody>
+          <a:bodyPr rtlCol="0" anchor="ctr" wrap="square" lIns="109728" rIns="109728"/>
+          <a:lstStyle/>
+          <a:p>
+            <a:pPr algn="ctr"/>
+            <a:r>
+              <a:rPr sz="1200" b="0">
+                <a:solidFill>
+                  <a:srgbClr val="242B3D"/>
+                </a:solidFill>
+                <a:latin typeface="Segoe UI"/>
+              </a:rPr>
+              <a:t>20.51%  (0.66s)</a:t>
+            </a:r>
+          </a:p>
+        </p:txBody>
+      </p:sp>
+      <p:sp>
+        <p:nvSpPr>
+          <p:cNvPr id="13" name="Rounded Rectangle 12"/>
+          <p:cNvSpPr/>
+          <p:nvPr/>
+        </p:nvSpPr>
+        <p:spPr>
+          <a:xfrm>
+            <a:off x="548640" y="2761488"/>
+            <a:ext cx="3383280" cy="566928"/>
+          </a:xfrm>
+          <a:prstGeom prst="roundRect">
+            <a:avLst/>
+          </a:prstGeom>
+          <a:solidFill>
+            <a:srgbClr val="F5F6FA"/>
+          </a:solidFill>
+          <a:ln>
+            <a:noFill/>
+          </a:ln>
+        </p:spPr>
+        <p:style>
+          <a:lnRef idx="1">
+            <a:schemeClr val="accent1"/>
+          </a:lnRef>
+          <a:fillRef idx="3">
+            <a:schemeClr val="accent1"/>
+          </a:fillRef>
+          <a:effectRef idx="2">
+            <a:schemeClr val="accent1"/>
+          </a:effectRef>
+          <a:fontRef idx="minor">
+            <a:schemeClr val="lt1"/>
+          </a:fontRef>
+        </p:style>
+        <p:txBody>
+          <a:bodyPr rtlCol="0" anchor="ctr" wrap="square" lIns="109728" rIns="109728"/>
+          <a:lstStyle/>
+          <a:p>
+            <a:pPr algn="l"/>
+            <a:r>
+              <a:rPr sz="1200" b="1">
+                <a:solidFill>
+                  <a:srgbClr val="1A233B"/>
+                </a:solidFill>
+                <a:latin typeface="Segoe UI"/>
+              </a:rPr>
+              <a:t>sample_handwriting.png (simulated)</a:t>
+            </a:r>
+          </a:p>
+        </p:txBody>
+      </p:sp>
+      <p:sp>
+        <p:nvSpPr>
+          <p:cNvPr id="14" name="Rounded Rectangle 13"/>
+          <p:cNvSpPr/>
+          <p:nvPr/>
+        </p:nvSpPr>
+        <p:spPr>
+          <a:xfrm>
+            <a:off x="3977639" y="2761488"/>
+            <a:ext cx="2468880" cy="566928"/>
+          </a:xfrm>
+          <a:prstGeom prst="roundRect">
+            <a:avLst/>
+          </a:prstGeom>
+          <a:solidFill>
+            <a:srgbClr val="FFFFFF"/>
+          </a:solidFill>
+          <a:ln w="15875">
+            <a:solidFill>
+              <a:srgbClr val="5A6472"/>
+            </a:solidFill>
+          </a:ln>
+        </p:spPr>
+        <p:style>
+          <a:lnRef idx="1">
+            <a:schemeClr val="accent1"/>
+          </a:lnRef>
+          <a:fillRef idx="3">
+            <a:schemeClr val="accent1"/>
+          </a:fillRef>
+          <a:effectRef idx="2">
+            <a:schemeClr val="accent1"/>
+          </a:effectRef>
+          <a:fontRef idx="minor">
+            <a:schemeClr val="lt1"/>
+          </a:fontRef>
+        </p:style>
+        <p:txBody>
+          <a:bodyPr rtlCol="0" anchor="ctr" wrap="square" lIns="109728" rIns="109728"/>
+          <a:lstStyle/>
+          <a:p>
+            <a:pPr algn="ctr"/>
+            <a:r>
+              <a:rPr sz="1200" b="0">
+                <a:solidFill>
+                  <a:srgbClr val="242B3D"/>
+                </a:solidFill>
+                <a:latin typeface="Segoe UI"/>
+              </a:rPr>
+              <a:t>35.29%  (20.9s)</a:t>
+            </a:r>
+          </a:p>
+        </p:txBody>
+      </p:sp>
+      <p:sp>
+        <p:nvSpPr>
+          <p:cNvPr id="15" name="Rounded Rectangle 14"/>
+          <p:cNvSpPr/>
+          <p:nvPr/>
+        </p:nvSpPr>
+        <p:spPr>
+          <a:xfrm>
+            <a:off x="6492240" y="2761488"/>
+            <a:ext cx="2468880" cy="566928"/>
+          </a:xfrm>
+          <a:prstGeom prst="roundRect">
+            <a:avLst/>
+          </a:prstGeom>
+          <a:solidFill>
+            <a:srgbClr val="FFFFFF"/>
+          </a:solidFill>
+          <a:ln w="15875">
+            <a:solidFill>
+              <a:srgbClr val="5A6472"/>
+            </a:solidFill>
+          </a:ln>
+        </p:spPr>
+        <p:style>
+          <a:lnRef idx="1">
+            <a:schemeClr val="accent1"/>
+          </a:lnRef>
+          <a:fillRef idx="3">
+            <a:schemeClr val="accent1"/>
+          </a:fillRef>
+          <a:effectRef idx="2">
+            <a:schemeClr val="accent1"/>
+          </a:effectRef>
+          <a:fontRef idx="minor">
+            <a:schemeClr val="lt1"/>
+          </a:fontRef>
+        </p:style>
+        <p:txBody>
+          <a:bodyPr rtlCol="0" anchor="ctr" wrap="square" lIns="109728" rIns="109728"/>
+          <a:lstStyle/>
+          <a:p>
+            <a:pPr algn="ctr"/>
+            <a:r>
+              <a:rPr sz="1200" b="0">
+                <a:solidFill>
+                  <a:srgbClr val="242B3D"/>
+                </a:solidFill>
+                <a:latin typeface="Segoe UI"/>
+              </a:rPr>
+              <a:t>13.24%  (0.35s)</a:t>
+            </a:r>
+          </a:p>
+        </p:txBody>
+      </p:sp>
+      <p:sp>
+        <p:nvSpPr>
+          <p:cNvPr id="16" name="Rounded Rectangle 15"/>
+          <p:cNvSpPr/>
+          <p:nvPr/>
+        </p:nvSpPr>
+        <p:spPr>
+          <a:xfrm>
+            <a:off x="9006840" y="2761488"/>
+            <a:ext cx="2606040" cy="566928"/>
+          </a:xfrm>
+          <a:prstGeom prst="roundRect">
+            <a:avLst/>
+          </a:prstGeom>
+          <a:solidFill>
+            <a:srgbClr val="FFFFFF"/>
+          </a:solidFill>
+          <a:ln w="15875">
+            <a:solidFill>
+              <a:srgbClr val="5A6472"/>
+            </a:solidFill>
+          </a:ln>
+        </p:spPr>
+        <p:style>
+          <a:lnRef idx="1">
+            <a:schemeClr val="accent1"/>
+          </a:lnRef>
+          <a:fillRef idx="3">
+            <a:schemeClr val="accent1"/>
+          </a:fillRef>
+          <a:effectRef idx="2">
+            <a:schemeClr val="accent1"/>
+          </a:effectRef>
+          <a:fontRef idx="minor">
+            <a:schemeClr val="lt1"/>
+          </a:fontRef>
+        </p:style>
+        <p:txBody>
+          <a:bodyPr rtlCol="0" anchor="ctr" wrap="square" lIns="109728" rIns="109728"/>
+          <a:lstStyle/>
+          <a:p>
+            <a:pPr algn="ctr"/>
+            <a:r>
+              <a:rPr sz="1200" b="0">
+                <a:solidFill>
+                  <a:srgbClr val="242B3D"/>
+                </a:solidFill>
+                <a:latin typeface="Segoe UI"/>
+              </a:rPr>
+              <a:t>13.97%  (0.28s)</a:t>
+            </a:r>
+          </a:p>
+        </p:txBody>
+      </p:sp>
+      <p:sp>
+        <p:nvSpPr>
+          <p:cNvPr id="17" name="Rounded Rectangle 16"/>
+          <p:cNvSpPr/>
+          <p:nvPr/>
+        </p:nvSpPr>
+        <p:spPr>
+          <a:xfrm>
+            <a:off x="548640" y="3419856"/>
+            <a:ext cx="3383280" cy="566928"/>
+          </a:xfrm>
+          <a:prstGeom prst="roundRect">
+            <a:avLst/>
+          </a:prstGeom>
+          <a:solidFill>
+            <a:srgbClr val="F5F6FA"/>
+          </a:solidFill>
+          <a:ln>
+            <a:noFill/>
+          </a:ln>
+        </p:spPr>
+        <p:style>
+          <a:lnRef idx="1">
+            <a:schemeClr val="accent1"/>
+          </a:lnRef>
+          <a:fillRef idx="3">
+            <a:schemeClr val="accent1"/>
+          </a:fillRef>
+          <a:effectRef idx="2">
+            <a:schemeClr val="accent1"/>
+          </a:effectRef>
+          <a:fontRef idx="minor">
+            <a:schemeClr val="lt1"/>
+          </a:fontRef>
+        </p:style>
+        <p:txBody>
+          <a:bodyPr rtlCol="0" anchor="ctr" wrap="square" lIns="109728" rIns="109728"/>
+          <a:lstStyle/>
+          <a:p>
+            <a:pPr algn="l"/>
+            <a:r>
+              <a:rPr sz="1200" b="1">
+                <a:solidFill>
+                  <a:srgbClr val="1A233B"/>
+                </a:solidFill>
+                <a:latin typeface="Segoe UI"/>
+              </a:rPr>
+              <a:t>sample_notice.png</a:t>
+            </a:r>
+          </a:p>
+        </p:txBody>
+      </p:sp>
+      <p:sp>
+        <p:nvSpPr>
+          <p:cNvPr id="18" name="Rounded Rectangle 17"/>
+          <p:cNvSpPr/>
+          <p:nvPr/>
+        </p:nvSpPr>
+        <p:spPr>
+          <a:xfrm>
+            <a:off x="3977639" y="3419856"/>
+            <a:ext cx="2468880" cy="566928"/>
+          </a:xfrm>
+          <a:prstGeom prst="roundRect">
+            <a:avLst/>
+          </a:prstGeom>
+          <a:solidFill>
+            <a:srgbClr val="FFFFFF"/>
+          </a:solidFill>
+          <a:ln w="15875">
+            <a:solidFill>
+              <a:srgbClr val="5A6472"/>
+            </a:solidFill>
+          </a:ln>
+        </p:spPr>
+        <p:style>
+          <a:lnRef idx="1">
+            <a:schemeClr val="accent1"/>
+          </a:lnRef>
+          <a:fillRef idx="3">
+            <a:schemeClr val="accent1"/>
+          </a:fillRef>
+          <a:effectRef idx="2">
+            <a:schemeClr val="accent1"/>
+          </a:effectRef>
+          <a:fontRef idx="minor">
+            <a:schemeClr val="lt1"/>
+          </a:fontRef>
+        </p:style>
+        <p:txBody>
+          <a:bodyPr rtlCol="0" anchor="ctr" wrap="square" lIns="109728" rIns="109728"/>
+          <a:lstStyle/>
+          <a:p>
+            <a:pPr algn="ctr"/>
+            <a:r>
+              <a:rPr sz="1200" b="0">
+                <a:solidFill>
+                  <a:srgbClr val="242B3D"/>
+                </a:solidFill>
+                <a:latin typeface="Segoe UI"/>
+              </a:rPr>
+              <a:t>50.27%  (99.5s)</a:t>
+            </a:r>
+          </a:p>
+        </p:txBody>
+      </p:sp>
+      <p:sp>
+        <p:nvSpPr>
+          <p:cNvPr id="19" name="Rounded Rectangle 18"/>
+          <p:cNvSpPr/>
+          <p:nvPr/>
+        </p:nvSpPr>
+        <p:spPr>
+          <a:xfrm>
+            <a:off x="6492240" y="3419856"/>
+            <a:ext cx="2468880" cy="566928"/>
+          </a:xfrm>
+          <a:prstGeom prst="roundRect">
+            <a:avLst/>
+          </a:prstGeom>
+          <a:solidFill>
+            <a:srgbClr val="FFFFFF"/>
+          </a:solidFill>
+          <a:ln w="15875">
+            <a:solidFill>
+              <a:srgbClr val="5A6472"/>
+            </a:solidFill>
+          </a:ln>
+        </p:spPr>
+        <p:style>
+          <a:lnRef idx="1">
+            <a:schemeClr val="accent1"/>
+          </a:lnRef>
+          <a:fillRef idx="3">
+            <a:schemeClr val="accent1"/>
+          </a:fillRef>
+          <a:effectRef idx="2">
+            <a:schemeClr val="accent1"/>
+          </a:effectRef>
+          <a:fontRef idx="minor">
+            <a:schemeClr val="lt1"/>
+          </a:fontRef>
+        </p:style>
+        <p:txBody>
+          <a:bodyPr rtlCol="0" anchor="ctr" wrap="square" lIns="109728" rIns="109728"/>
+          <a:lstStyle/>
+          <a:p>
+            <a:pPr algn="ctr"/>
+            <a:r>
+              <a:rPr sz="1200" b="0">
+                <a:solidFill>
+                  <a:srgbClr val="242B3D"/>
+                </a:solidFill>
+                <a:latin typeface="Segoe UI"/>
+              </a:rPr>
+              <a:t>23.38%  (0.71s)</a:t>
+            </a:r>
+          </a:p>
+        </p:txBody>
+      </p:sp>
+      <p:sp>
+        <p:nvSpPr>
+          <p:cNvPr id="20" name="Rounded Rectangle 19"/>
+          <p:cNvSpPr/>
+          <p:nvPr/>
+        </p:nvSpPr>
+        <p:spPr>
+          <a:xfrm>
+            <a:off x="9006840" y="3419856"/>
+            <a:ext cx="2606040" cy="566928"/>
+          </a:xfrm>
+          <a:prstGeom prst="roundRect">
+            <a:avLst/>
+          </a:prstGeom>
+          <a:solidFill>
+            <a:srgbClr val="FFFFFF"/>
+          </a:solidFill>
+          <a:ln w="15875">
+            <a:solidFill>
+              <a:srgbClr val="5A6472"/>
+            </a:solidFill>
+          </a:ln>
+        </p:spPr>
+        <p:style>
+          <a:lnRef idx="1">
+            <a:schemeClr val="accent1"/>
+          </a:lnRef>
+          <a:fillRef idx="3">
+            <a:schemeClr val="accent1"/>
+          </a:fillRef>
+          <a:effectRef idx="2">
+            <a:schemeClr val="accent1"/>
+          </a:effectRef>
+          <a:fontRef idx="minor">
+            <a:schemeClr val="lt1"/>
+          </a:fontRef>
+        </p:style>
+        <p:txBody>
+          <a:bodyPr rtlCol="0" anchor="ctr" wrap="square" lIns="109728" rIns="109728"/>
+          <a:lstStyle/>
+          <a:p>
+            <a:pPr algn="ctr"/>
+            <a:r>
+              <a:rPr sz="1200" b="0">
+                <a:solidFill>
+                  <a:srgbClr val="242B3D"/>
+                </a:solidFill>
+                <a:latin typeface="Segoe UI"/>
+              </a:rPr>
+              <a:t>22.16%  (2.60s)</a:t>
+            </a:r>
+          </a:p>
+        </p:txBody>
+      </p:sp>
+      <p:sp>
+        <p:nvSpPr>
+          <p:cNvPr id="21" name="Rounded Rectangle 20"/>
+          <p:cNvSpPr/>
+          <p:nvPr/>
+        </p:nvSpPr>
+        <p:spPr>
+          <a:xfrm>
+            <a:off x="548640" y="4078224"/>
+            <a:ext cx="3383280" cy="566928"/>
+          </a:xfrm>
+          <a:prstGeom prst="roundRect">
+            <a:avLst/>
+          </a:prstGeom>
+          <a:solidFill>
+            <a:srgbClr val="F5F6FA"/>
+          </a:solidFill>
+          <a:ln>
+            <a:noFill/>
+          </a:ln>
+        </p:spPr>
+        <p:style>
+          <a:lnRef idx="1">
+            <a:schemeClr val="accent1"/>
+          </a:lnRef>
+          <a:fillRef idx="3">
+            <a:schemeClr val="accent1"/>
+          </a:fillRef>
+          <a:effectRef idx="2">
+            <a:schemeClr val="accent1"/>
+          </a:effectRef>
+          <a:fontRef idx="minor">
+            <a:schemeClr val="lt1"/>
+          </a:fontRef>
+        </p:style>
+        <p:txBody>
+          <a:bodyPr rtlCol="0" anchor="ctr" wrap="square" lIns="109728" rIns="109728"/>
+          <a:lstStyle/>
+          <a:p>
+            <a:pPr algn="l"/>
+            <a:r>
+              <a:rPr sz="1200" b="1">
+                <a:solidFill>
+                  <a:srgbClr val="1A233B"/>
+                </a:solidFill>
+                <a:latin typeface="Segoe UI"/>
+              </a:rPr>
+              <a:t>sample_textbook.png</a:t>
+            </a:r>
+          </a:p>
+        </p:txBody>
+      </p:sp>
+      <p:sp>
+        <p:nvSpPr>
+          <p:cNvPr id="22" name="Rounded Rectangle 21"/>
+          <p:cNvSpPr/>
+          <p:nvPr/>
+        </p:nvSpPr>
+        <p:spPr>
+          <a:xfrm>
+            <a:off x="3977639" y="4078224"/>
+            <a:ext cx="2468880" cy="566928"/>
+          </a:xfrm>
+          <a:prstGeom prst="roundRect">
+            <a:avLst/>
+          </a:prstGeom>
+          <a:solidFill>
+            <a:srgbClr val="FFFFFF"/>
+          </a:solidFill>
+          <a:ln w="15875">
+            <a:solidFill>
+              <a:srgbClr val="5A6472"/>
+            </a:solidFill>
+          </a:ln>
+        </p:spPr>
+        <p:style>
+          <a:lnRef idx="1">
+            <a:schemeClr val="accent1"/>
+          </a:lnRef>
+          <a:fillRef idx="3">
+            <a:schemeClr val="accent1"/>
+          </a:fillRef>
+          <a:effectRef idx="2">
+            <a:schemeClr val="accent1"/>
+          </a:effectRef>
+          <a:fontRef idx="minor">
+            <a:schemeClr val="lt1"/>
+          </a:fontRef>
+        </p:style>
+        <p:txBody>
+          <a:bodyPr rtlCol="0" anchor="ctr" wrap="square" lIns="109728" rIns="109728"/>
+          <a:lstStyle/>
+          <a:p>
+            <a:pPr algn="ctr"/>
+            <a:r>
+              <a:rPr sz="1200" b="0">
+                <a:solidFill>
+                  <a:srgbClr val="C62828"/>
+                </a:solidFill>
+                <a:latin typeface="Segoe UI"/>
+              </a:rPr>
+              <a:t>rate-limited  ✗</a:t>
+            </a:r>
+          </a:p>
+        </p:txBody>
+      </p:sp>
+      <p:sp>
+        <p:nvSpPr>
+          <p:cNvPr id="23" name="Rounded Rectangle 22"/>
+          <p:cNvSpPr/>
+          <p:nvPr/>
+        </p:nvSpPr>
+        <p:spPr>
+          <a:xfrm>
+            <a:off x="6492240" y="4078224"/>
+            <a:ext cx="2468880" cy="566928"/>
+          </a:xfrm>
+          <a:prstGeom prst="roundRect">
+            <a:avLst/>
+          </a:prstGeom>
+          <a:solidFill>
+            <a:srgbClr val="FFFFFF"/>
+          </a:solidFill>
+          <a:ln w="15875">
+            <a:solidFill>
+              <a:srgbClr val="5A6472"/>
+            </a:solidFill>
+          </a:ln>
+        </p:spPr>
+        <p:style>
+          <a:lnRef idx="1">
+            <a:schemeClr val="accent1"/>
+          </a:lnRef>
+          <a:fillRef idx="3">
+            <a:schemeClr val="accent1"/>
+          </a:fillRef>
+          <a:effectRef idx="2">
+            <a:schemeClr val="accent1"/>
+          </a:effectRef>
+          <a:fontRef idx="minor">
+            <a:schemeClr val="lt1"/>
+          </a:fontRef>
+        </p:style>
+        <p:txBody>
+          <a:bodyPr rtlCol="0" anchor="ctr" wrap="square" lIns="109728" rIns="109728"/>
+          <a:lstStyle/>
+          <a:p>
+            <a:pPr algn="ctr"/>
+            <a:r>
+              <a:rPr sz="1200" b="0">
+                <a:solidFill>
+                  <a:srgbClr val="242B3D"/>
+                </a:solidFill>
+                <a:latin typeface="Segoe UI"/>
+              </a:rPr>
+              <a:t>17.62%  (0.94s)</a:t>
+            </a:r>
+          </a:p>
+        </p:txBody>
+      </p:sp>
+      <p:sp>
+        <p:nvSpPr>
+          <p:cNvPr id="24" name="Rounded Rectangle 23"/>
+          <p:cNvSpPr/>
+          <p:nvPr/>
+        </p:nvSpPr>
+        <p:spPr>
+          <a:xfrm>
+            <a:off x="9006840" y="4078224"/>
+            <a:ext cx="2606040" cy="566928"/>
+          </a:xfrm>
+          <a:prstGeom prst="roundRect">
+            <a:avLst/>
+          </a:prstGeom>
+          <a:solidFill>
+            <a:srgbClr val="FFFFFF"/>
+          </a:solidFill>
+          <a:ln w="15875">
+            <a:solidFill>
+              <a:srgbClr val="5A6472"/>
+            </a:solidFill>
+          </a:ln>
+        </p:spPr>
+        <p:style>
+          <a:lnRef idx="1">
+            <a:schemeClr val="accent1"/>
+          </a:lnRef>
+          <a:fillRef idx="3">
+            <a:schemeClr val="accent1"/>
+          </a:fillRef>
+          <a:effectRef idx="2">
+            <a:schemeClr val="accent1"/>
+          </a:effectRef>
+          <a:fontRef idx="minor">
+            <a:schemeClr val="lt1"/>
+          </a:fontRef>
+        </p:style>
+        <p:txBody>
+          <a:bodyPr rtlCol="0" anchor="ctr" wrap="square" lIns="109728" rIns="109728"/>
+          <a:lstStyle/>
+          <a:p>
+            <a:pPr algn="ctr"/>
+            <a:r>
+              <a:rPr sz="1200" b="0">
+                <a:solidFill>
+                  <a:srgbClr val="242B3D"/>
+                </a:solidFill>
+                <a:latin typeface="Segoe UI"/>
+              </a:rPr>
+              <a:t>16.25%  (0.92s)</a:t>
+            </a:r>
+          </a:p>
+        </p:txBody>
+      </p:sp>
+      <p:sp>
+        <p:nvSpPr>
+          <p:cNvPr id="25" name="Rounded Rectangle 24"/>
+          <p:cNvSpPr/>
+          <p:nvPr/>
+        </p:nvSpPr>
+        <p:spPr>
+          <a:xfrm>
+            <a:off x="548640" y="4937760"/>
+            <a:ext cx="11064240" cy="1143000"/>
+          </a:xfrm>
+          <a:prstGeom prst="roundRect">
+            <a:avLst/>
+          </a:prstGeom>
+          <a:solidFill>
+            <a:srgbClr val="FDECEC"/>
+          </a:solidFill>
+          <a:ln w="15875">
+            <a:solidFill>
+              <a:srgbClr val="C62828"/>
+            </a:solidFill>
+          </a:ln>
+        </p:spPr>
+        <p:style>
+          <a:lnRef idx="1">
+            <a:schemeClr val="accent1"/>
+          </a:lnRef>
+          <a:fillRef idx="3">
+            <a:schemeClr val="accent1"/>
+          </a:fillRef>
+          <a:effectRef idx="2">
+            <a:schemeClr val="accent1"/>
+          </a:effectRef>
+          <a:fontRef idx="minor">
+            <a:schemeClr val="lt1"/>
+          </a:fontRef>
+        </p:style>
+        <p:txBody>
+          <a:bodyPr rtlCol="0" anchor="ctr" wrap="square" lIns="109728" rIns="109728"/>
+          <a:lstStyle/>
+          <a:p>
+            <a:pPr algn="ctr"/>
+            <a:r>
+              <a:rPr sz="1300" b="0">
+                <a:solidFill>
+                  <a:srgbClr val="1A233B"/>
+                </a:solidFill>
+                <a:latin typeface="Segoe UI"/>
+              </a:rPr>
+              <a:t>Groq varies run to run and free-tier rate limits can fail a call outright (textbook row above). On these samples the offline default is both more accurate and ~30× faster — that's why Tesseract is the default and Groq stays optional. Both are one dropdown apart; compare on your own documents.</a:t>
+            </a:r>
+          </a:p>
+        </p:txBody>
+      </p:sp>
+      <p:sp>
+        <p:nvSpPr>
+          <p:cNvPr id="26" name="TextBox 25"/>
+          <p:cNvSpPr txBox="1"/>
+          <p:nvPr/>
+        </p:nvSpPr>
+        <p:spPr>
+          <a:xfrm>
+            <a:off x="548640" y="6446520"/>
+            <a:ext cx="8229600" cy="320040"/>
+          </a:xfrm>
+          <a:prstGeom prst="rect">
+            <a:avLst/>
+          </a:prstGeom>
+          <a:noFill/>
+        </p:spPr>
+        <p:txBody>
+          <a:bodyPr wrap="square">
+            <a:spAutoFit/>
+          </a:bodyPr>
+          <a:lstStyle/>
+          <a:p>
+            <a:pPr algn="l">
+              <a:lnSpc>
+                <a:spcPct val="100000"/>
+              </a:lnSpc>
+              <a:spcAft>
+                <a:spcPts val="450"/>
+              </a:spcAft>
+            </a:pPr>
+            <a:r>
+              <a:rPr sz="1000" b="0">
+                <a:solidFill>
+                  <a:srgbClr val="5A6472"/>
+                </a:solidFill>
+                <a:latin typeface="Segoe UI"/>
+              </a:rPr>
+              <a:t>ಕನ್ನಡ ಲಿಪಿ ಮಿತ್ರ · Kannada Digital Innovation Hackathon 2026 · PS-05</a:t>
+            </a:r>
+          </a:p>
+        </p:txBody>
+      </p:sp>
+      <p:sp>
+        <p:nvSpPr>
+          <p:cNvPr id="27" name="TextBox 26"/>
+          <p:cNvSpPr txBox="1"/>
+          <p:nvPr/>
+        </p:nvSpPr>
+        <p:spPr>
+          <a:xfrm>
+            <a:off x="11155680" y="6446520"/>
+            <a:ext cx="731520" cy="320040"/>
+          </a:xfrm>
+          <a:prstGeom prst="rect">
+            <a:avLst/>
+          </a:prstGeom>
+          <a:noFill/>
+        </p:spPr>
+        <p:txBody>
+          <a:bodyPr wrap="square">
+            <a:spAutoFit/>
+          </a:bodyPr>
+          <a:lstStyle/>
+          <a:p>
+            <a:pPr algn="r">
+              <a:lnSpc>
+                <a:spcPct val="100000"/>
+              </a:lnSpc>
+              <a:spcAft>
+                <a:spcPts val="450"/>
+              </a:spcAft>
+            </a:pPr>
+            <a:r>
+              <a:rPr sz="1000" b="0">
+                <a:solidFill>
+                  <a:srgbClr val="5A6472"/>
+                </a:solidFill>
+                <a:latin typeface="Segoe UI"/>
+              </a:rPr>
+              <a:t>8/9</a:t>
+            </a:r>
+          </a:p>
+        </p:txBody>
+      </p:sp>
+    </p:spTree>
+  </p:cSld>
+  <p:clrMapOvr>
+    <a:masterClrMapping/>
+  </p:clrMapOvr>
+</p:sld>
+</file>
+
+<file path=ppt/slides/slide9.xml><?xml version="1.0" encoding="utf-8"?>
+<p:sld xmlns:a="http://schemas.openxmlformats.org/drawingml/2006/main" xmlns:p="http://schemas.openxmlformats.org/presentationml/2006/main" xmlns:r="http://schemas.openxmlformats.org/officeDocument/2006/relationships">
+  <p:cSld>
+    <p:bg>
+      <p:bgPr>
+        <a:solidFill>
+          <a:srgbClr val="FFFFFF"/>
+        </a:solidFill>
+        <a:effectLst/>
+      </p:bgPr>
+    </p:bg>
+    <p:spTree>
+      <p:nvGrpSpPr>
+        <p:cNvPr id="1" name=""/>
+        <p:cNvGrpSpPr/>
+        <p:nvPr/>
+      </p:nvGrpSpPr>
+      <p:grpSpPr/>
+      <p:sp>
+        <p:nvSpPr>
+          <p:cNvPr id="2" name="Rectangle 1"/>
+          <p:cNvSpPr/>
+          <p:nvPr/>
+        </p:nvSpPr>
+        <p:spPr>
+          <a:xfrm>
+            <a:off x="0" y="0"/>
+            <a:ext cx="12191695" cy="146304"/>
+          </a:xfrm>
+          <a:prstGeom prst="rect">
+            <a:avLst/>
+          </a:prstGeom>
+          <a:solidFill>
+            <a:srgbClr val="C62828"/>
+          </a:solidFill>
+          <a:ln>
+            <a:noFill/>
+          </a:ln>
+        </p:spPr>
+        <p:style>
+          <a:lnRef idx="1">
+            <a:schemeClr val="accent1"/>
+          </a:lnRef>
+          <a:fillRef idx="3">
+            <a:schemeClr val="accent1"/>
+          </a:fillRef>
+          <a:effectRef idx="2">
+            <a:schemeClr val="accent1"/>
+          </a:effectRef>
+          <a:fontRef idx="minor">
+            <a:schemeClr val="lt1"/>
+          </a:fontRef>
+        </p:style>
+        <p:txBody>
+          <a:bodyPr rtlCol="0" anchor="ctr" wrap="square" lIns="109728" rIns="109728"/>
+          <a:lstStyle/>
+          <a:p>
+            <a:pPr algn="l"/>
+            <a:r>
+              <a:rPr sz="1600" b="0">
+                <a:solidFill>
+                  <a:srgbClr val="242B3D"/>
+                </a:solidFill>
+                <a:latin typeface="Segoe UI"/>
+              </a:rPr>
+              <a:t/>
+            </a:r>
+          </a:p>
+        </p:txBody>
+      </p:sp>
+      <p:sp>
+        <p:nvSpPr>
+          <p:cNvPr id="3" name="TextBox 2"/>
+          <p:cNvSpPr txBox="1"/>
+          <p:nvPr/>
+        </p:nvSpPr>
+        <p:spPr>
+          <a:xfrm>
+            <a:off x="548640" y="320040"/>
+            <a:ext cx="11064240" cy="731520"/>
+          </a:xfrm>
+          <a:prstGeom prst="rect">
+            <a:avLst/>
+          </a:prstGeom>
+          <a:noFill/>
+        </p:spPr>
+        <p:txBody>
+          <a:bodyPr wrap="square">
+            <a:spAutoFit/>
+          </a:bodyPr>
+          <a:lstStyle/>
+          <a:p>
+            <a:pPr algn="l">
+              <a:lnSpc>
+                <a:spcPct val="100000"/>
+              </a:lnSpc>
+              <a:spcAft>
+                <a:spcPts val="1440"/>
+              </a:spcAft>
+            </a:pPr>
+            <a:r>
+              <a:rPr sz="3200" b="1">
+                <a:solidFill>
+                  <a:srgbClr val="1A233B"/>
+                </a:solidFill>
+                <a:latin typeface="Segoe UI"/>
+              </a:rPr>
               <a:t>Conclusion &amp; Future Scope</a:t>
             </a:r>
           </a:p>
@@ -9007,7 +10358,7 @@
                 </a:solidFill>
                 <a:latin typeface="Segoe UI"/>
               </a:rPr>
-              <a:t>•  Handles images, multi-page PDFs and handwriting — every input type PS-05 asks for</a:t>
+              <a:t>•  Handles images and multi-page PDFs, plus an honestly-labelled simulated handwriting sample</a:t>
             </a:r>
           </a:p>
           <a:p>
@@ -9026,7 +10377,7 @@
                 </a:solidFill>
                 <a:latin typeface="Segoe UI"/>
               </a:rPr>
-              <a:t>•  Validation layer delivers trustworthy output where traditional OCR silently fails</a:t>
+              <a:t>•  Groq-path validation (script retry + Tesseract cross-check) flags silent failures raw OCR never reports</a:t>
             </a:r>
           </a:p>
           <a:p>
@@ -9045,7 +10396,7 @@
                 </a:solidFill>
                 <a:latin typeface="Segoe UI"/>
               </a:rPr>
-              <a:t>•  Engine-agnostic core runs on free LLM quotas today — or fully offline for zero-cost deployments</a:t>
+              <a:t>•  Offline-first core runs with zero API keys; an optional Groq key adds the vision LLM and translation</a:t>
             </a:r>
           </a:p>
           <a:p>
@@ -9167,7 +10518,7 @@
                 </a:solidFill>
                 <a:latin typeface="Segoe UI"/>
               </a:rPr>
-              <a:t>•  On-device fine-tuned IndicOCR model for offline handwriting</a:t>
+              <a:t>•  Real handwriting recognition research (today's demo sample is simulated)</a:t>
             </a:r>
           </a:p>
           <a:p>
@@ -9341,7 +10692,7 @@
                 </a:solidFill>
                 <a:latin typeface="Segoe UI"/>
               </a:rPr>
-              <a:t>8/8</a:t>
+              <a:t>9/9</a:t>
             </a:r>
           </a:p>
         </p:txBody>

</xml_diff>

<commit_message>
docs: honest handwriting claims — experimental only, never-guess prompt, fresh Levenshtein CER table
</commit_message>
<xml_diff>
--- a/docs/Kannada_Lipi_Mitra_Presentation.pptx
+++ b/docs/Kannada_Lipi_Mitra_Presentation.pptx
@@ -5688,7 +5688,7 @@
                 </a:solidFill>
                 <a:latin typeface="Segoe UI"/>
               </a:rPr>
-              <a:t>Upload, drag-drop, camera capture or multi-page PDF (page-wise OCR with per-page markers); plus four sample documents — sample 4 is simulated handwriting generated by script, not real handwriting.</a:t>
+              <a:t>Upload, drag-drop, camera capture or multi-page PDF (page-wise OCR with per-page markers); plus four sample documents — sample 4 is simulated handwriting generated by script, not real handwriting. Handwriting mode is experimental (tested on one simulated sample only; Tesseract kan is print-trained).</a:t>
             </a:r>
           </a:p>
         </p:txBody>
@@ -9247,7 +9247,7 @@
                 </a:solidFill>
                 <a:latin typeface="Segoe UI"/>
               </a:rPr>
-              <a:t>52.35%  (48.9s)</a:t>
+              <a:t>52.35%  (48.2s)</a:t>
             </a:r>
           </a:p>
         </p:txBody>
@@ -9301,7 +9301,7 @@
                 </a:solidFill>
                 <a:latin typeface="Segoe UI"/>
               </a:rPr>
-              <a:t>20.75%  (0.84s)</a:t>
+              <a:t>20.75%  (1.63s)</a:t>
             </a:r>
           </a:p>
         </p:txBody>
@@ -9355,7 +9355,7 @@
                 </a:solidFill>
                 <a:latin typeface="Segoe UI"/>
               </a:rPr>
-              <a:t>20.51%  (0.66s)</a:t>
+              <a:t>20.51%  (1.45s)</a:t>
             </a:r>
           </a:p>
         </p:txBody>
@@ -9461,7 +9461,7 @@
                 </a:solidFill>
                 <a:latin typeface="Segoe UI"/>
               </a:rPr>
-              <a:t>35.29%  (20.9s)</a:t>
+              <a:t>47.06%  (19.0s)</a:t>
             </a:r>
           </a:p>
         </p:txBody>
@@ -9515,7 +9515,7 @@
                 </a:solidFill>
                 <a:latin typeface="Segoe UI"/>
               </a:rPr>
-              <a:t>13.24%  (0.35s)</a:t>
+              <a:t>11.03%  (0.56s)</a:t>
             </a:r>
           </a:p>
         </p:txBody>
@@ -9569,7 +9569,7 @@
                 </a:solidFill>
                 <a:latin typeface="Segoe UI"/>
               </a:rPr>
-              <a:t>13.97%  (0.28s)</a:t>
+              <a:t>13.24%  (0.63s)</a:t>
             </a:r>
           </a:p>
         </p:txBody>
@@ -9675,7 +9675,7 @@
                 </a:solidFill>
                 <a:latin typeface="Segoe UI"/>
               </a:rPr>
-              <a:t>50.27%  (99.5s)</a:t>
+              <a:t>50.27%  (91.6s)</a:t>
             </a:r>
           </a:p>
         </p:txBody>
@@ -9729,7 +9729,7 @@
                 </a:solidFill>
                 <a:latin typeface="Segoe UI"/>
               </a:rPr>
-              <a:t>23.38%  (0.71s)</a:t>
+              <a:t>23.38%  (1.46s)</a:t>
             </a:r>
           </a:p>
         </p:txBody>
@@ -9783,7 +9783,7 @@
                 </a:solidFill>
                 <a:latin typeface="Segoe UI"/>
               </a:rPr>
-              <a:t>22.16%  (2.60s)</a:t>
+              <a:t>22.16%  (1.42s)</a:t>
             </a:r>
           </a:p>
         </p:txBody>
@@ -9885,11 +9885,11 @@
             <a:r>
               <a:rPr sz="1200" b="0">
                 <a:solidFill>
-                  <a:srgbClr val="C62828"/>
-                </a:solidFill>
-                <a:latin typeface="Segoe UI"/>
-              </a:rPr>
-              <a:t>rate-limited  ✗</a:t>
+                  <a:srgbClr val="242B3D"/>
+                </a:solidFill>
+                <a:latin typeface="Segoe UI"/>
+              </a:rPr>
+              <a:t>56.50%  (90.1s)</a:t>
             </a:r>
           </a:p>
         </p:txBody>
@@ -9943,7 +9943,7 @@
                 </a:solidFill>
                 <a:latin typeface="Segoe UI"/>
               </a:rPr>
-              <a:t>17.62%  (0.94s)</a:t>
+              <a:t>17.62%  (1.65s)</a:t>
             </a:r>
           </a:p>
         </p:txBody>
@@ -9997,7 +9997,7 @@
                 </a:solidFill>
                 <a:latin typeface="Segoe UI"/>
               </a:rPr>
-              <a:t>16.25%  (0.92s)</a:t>
+              <a:t>16.25%  (1.60s)</a:t>
             </a:r>
           </a:p>
         </p:txBody>
@@ -10051,7 +10051,7 @@
                 </a:solidFill>
                 <a:latin typeface="Segoe UI"/>
               </a:rPr>
-              <a:t>Groq varies run to run and free-tier rate limits can fail a call outright (textbook row above). On these samples the offline default is both more accurate and ~30× faster — that's why Tesseract is the default and Groq stays optional. Both are one dropdown apart; compare on your own documents.</a:t>
+              <a:t>Groq varies run to run and free-tier rate limits add long backoffs (visible in this run). On these samples the offline default is both more accurate and ~30x faster — that's why Tesseract is the default and Groq stays optional. Both are one dropdown apart; compare on your own documents.</a:t>
             </a:r>
           </a:p>
         </p:txBody>
@@ -10358,7 +10358,7 @@
                 </a:solidFill>
                 <a:latin typeface="Segoe UI"/>
               </a:rPr>
-              <a:t>•  Handles images and multi-page PDFs, plus an honestly-labelled simulated handwriting sample</a:t>
+              <a:t>•  Handles images and multi-page PDFs, plus a simulated handwriting sample with an experimental handwriting mode</a:t>
             </a:r>
           </a:p>
           <a:p>
@@ -10518,7 +10518,7 @@
                 </a:solidFill>
                 <a:latin typeface="Segoe UI"/>
               </a:rPr>
-              <a:t>•  Real handwriting recognition research (today's demo sample is simulated)</a:t>
+              <a:t>•  Real handwriting recognition (handwriting mode is experimental; demo sample is simulated; Tesseract kan is print-trained)</a:t>
             </a:r>
           </a:p>
           <a:p>

</xml_diff>